<commit_message>
Working 2 region models. Tried with opposite trend of excitability changes.
</commit_message>
<xml_diff>
--- a/work_update.pptx
+++ b/work_update.pptx
@@ -12,7 +12,7 @@
     <p:sldId id="259" r:id="rId3"/>
     <p:sldId id="261" r:id="rId4"/>
     <p:sldId id="262" r:id="rId5"/>
-    <p:sldId id="263" r:id="rId6"/>
+    <p:sldId id="264" r:id="rId6"/>
   </p:sldIdLst>
   <p:sldSz cx="12192000" cy="6858000"/>
   <p:notesSz cx="6858000" cy="9144000"/>
@@ -201,7 +201,7 @@
           <a:p>
             <a:fld id="{C5277F1B-8BFE-6F4C-BE59-07460FCF0A8C}" type="datetimeFigureOut">
               <a:rPr lang="en-US" smtClean="0"/>
-              <a:t>10/29/25</a:t>
+              <a:t>11/3/25</a:t>
             </a:fld>
             <a:endParaRPr lang="en-US"/>
           </a:p>
@@ -534,7 +534,7 @@
           <a:p>
             <a:fld id="{62B653BF-6F47-F14F-A746-DDF7BB6031C9}" type="slidenum">
               <a:rPr lang="en-US" smtClean="0"/>
-              <a:t>3</a:t>
+              <a:t>2</a:t>
             </a:fld>
             <a:endParaRPr lang="en-US"/>
           </a:p>
@@ -543,7 +543,7 @@
     </p:spTree>
     <p:extLst>
       <p:ext uri="{BB962C8B-B14F-4D97-AF65-F5344CB8AC3E}">
-        <p14:creationId xmlns:p14="http://schemas.microsoft.com/office/powerpoint/2010/main" val="3881481358"/>
+        <p14:creationId xmlns:p14="http://schemas.microsoft.com/office/powerpoint/2010/main" val="2725198203"/>
       </p:ext>
     </p:extLst>
   </p:cSld>
@@ -558,10 +558,94 @@
   <p:cSld>
     <p:spTree>
       <p:nvGrpSpPr>
+        <p:cNvPr id="1" name=""/>
+        <p:cNvGrpSpPr/>
+        <p:nvPr/>
+      </p:nvGrpSpPr>
+      <p:grpSpPr>
+        <a:xfrm>
+          <a:off x="0" y="0"/>
+          <a:ext cx="0" cy="0"/>
+          <a:chOff x="0" y="0"/>
+          <a:chExt cx="0" cy="0"/>
+        </a:xfrm>
+      </p:grpSpPr>
+      <p:sp>
+        <p:nvSpPr>
+          <p:cNvPr id="2" name="Slide Image Placeholder 1"/>
+          <p:cNvSpPr>
+            <a:spLocks noGrp="1" noRot="1" noChangeAspect="1"/>
+          </p:cNvSpPr>
+          <p:nvPr>
+            <p:ph type="sldImg"/>
+          </p:nvPr>
+        </p:nvSpPr>
+        <p:spPr/>
+      </p:sp>
+      <p:sp>
+        <p:nvSpPr>
+          <p:cNvPr id="3" name="Notes Placeholder 2"/>
+          <p:cNvSpPr>
+            <a:spLocks noGrp="1"/>
+          </p:cNvSpPr>
+          <p:nvPr>
+            <p:ph type="body" idx="1"/>
+          </p:nvPr>
+        </p:nvSpPr>
+        <p:spPr/>
+        <p:txBody>
+          <a:bodyPr/>
+          <a:lstStyle/>
+          <a:p>
+            <a:endParaRPr lang="en-US" dirty="0"/>
+          </a:p>
+        </p:txBody>
+      </p:sp>
+      <p:sp>
+        <p:nvSpPr>
+          <p:cNvPr id="4" name="Slide Number Placeholder 3"/>
+          <p:cNvSpPr>
+            <a:spLocks noGrp="1"/>
+          </p:cNvSpPr>
+          <p:nvPr>
+            <p:ph type="sldNum" sz="quarter" idx="5"/>
+          </p:nvPr>
+        </p:nvSpPr>
+        <p:spPr/>
+        <p:txBody>
+          <a:bodyPr/>
+          <a:lstStyle/>
+          <a:p>
+            <a:fld id="{62B653BF-6F47-F14F-A746-DDF7BB6031C9}" type="slidenum">
+              <a:rPr lang="en-US" smtClean="0"/>
+              <a:t>3</a:t>
+            </a:fld>
+            <a:endParaRPr lang="en-US"/>
+          </a:p>
+        </p:txBody>
+      </p:sp>
+    </p:spTree>
+    <p:extLst>
+      <p:ext uri="{BB962C8B-B14F-4D97-AF65-F5344CB8AC3E}">
+        <p14:creationId xmlns:p14="http://schemas.microsoft.com/office/powerpoint/2010/main" val="3881481358"/>
+      </p:ext>
+    </p:extLst>
+  </p:cSld>
+  <p:clrMapOvr>
+    <a:masterClrMapping/>
+  </p:clrMapOvr>
+</p:notes>
+</file>
+
+<file path=ppt/notesSlides/notesSlide3.xml><?xml version="1.0" encoding="utf-8"?>
+<p:notes xmlns:a="http://schemas.openxmlformats.org/drawingml/2006/main" xmlns:r="http://schemas.openxmlformats.org/officeDocument/2006/relationships" xmlns:p="http://schemas.openxmlformats.org/presentationml/2006/main">
+  <p:cSld>
+    <p:spTree>
+      <p:nvGrpSpPr>
         <p:cNvPr id="1" name="">
           <a:extLst>
             <a:ext uri="{FF2B5EF4-FFF2-40B4-BE49-F238E27FC236}">
-              <a16:creationId xmlns:a16="http://schemas.microsoft.com/office/drawing/2014/main" id="{A2E2ED4F-DD5B-CF52-923D-2BB9D1F15A55}"/>
+              <a16:creationId xmlns:a16="http://schemas.microsoft.com/office/drawing/2014/main" id="{47FDDCEA-81E3-BF28-1405-860A4C9FAE82}"/>
             </a:ext>
           </a:extLst>
         </p:cNvPr>
@@ -581,7 +665,7 @@
           <p:cNvPr id="2" name="Slide Image Placeholder 1">
             <a:extLst>
               <a:ext uri="{FF2B5EF4-FFF2-40B4-BE49-F238E27FC236}">
-                <a16:creationId xmlns:a16="http://schemas.microsoft.com/office/drawing/2014/main" id="{98C0750F-601D-CCC2-F71E-17936B061526}"/>
+                <a16:creationId xmlns:a16="http://schemas.microsoft.com/office/drawing/2014/main" id="{CE42DB86-846A-A3E3-63FA-803D8B9F731D}"/>
               </a:ext>
             </a:extLst>
           </p:cNvPr>
@@ -599,7 +683,7 @@
           <p:cNvPr id="3" name="Notes Placeholder 2">
             <a:extLst>
               <a:ext uri="{FF2B5EF4-FFF2-40B4-BE49-F238E27FC236}">
-                <a16:creationId xmlns:a16="http://schemas.microsoft.com/office/drawing/2014/main" id="{67DBCFF1-880D-09C6-2EB0-097E33F2F703}"/>
+                <a16:creationId xmlns:a16="http://schemas.microsoft.com/office/drawing/2014/main" id="{D460B21E-FC88-D8BB-3A35-7D608AA5652E}"/>
               </a:ext>
             </a:extLst>
           </p:cNvPr>
@@ -624,7 +708,7 @@
           <p:cNvPr id="4" name="Slide Number Placeholder 3">
             <a:extLst>
               <a:ext uri="{FF2B5EF4-FFF2-40B4-BE49-F238E27FC236}">
-                <a16:creationId xmlns:a16="http://schemas.microsoft.com/office/drawing/2014/main" id="{C815C79E-B54F-E611-9886-77B820F300D1}"/>
+                <a16:creationId xmlns:a16="http://schemas.microsoft.com/office/drawing/2014/main" id="{A408E2C4-F779-4C3F-5F0D-AA4365F8BDE1}"/>
               </a:ext>
             </a:extLst>
           </p:cNvPr>
@@ -651,7 +735,7 @@
     </p:spTree>
     <p:extLst>
       <p:ext uri="{BB962C8B-B14F-4D97-AF65-F5344CB8AC3E}">
-        <p14:creationId xmlns:p14="http://schemas.microsoft.com/office/powerpoint/2010/main" val="2048792072"/>
+        <p14:creationId xmlns:p14="http://schemas.microsoft.com/office/powerpoint/2010/main" val="2827649689"/>
       </p:ext>
     </p:extLst>
   </p:cSld>
@@ -810,7 +894,7 @@
           <a:p>
             <a:fld id="{E2316B49-29CB-5341-97D4-8A75BDD8022D}" type="datetimeFigureOut">
               <a:rPr lang="en-US" smtClean="0"/>
-              <a:t>10/29/25</a:t>
+              <a:t>11/3/25</a:t>
             </a:fld>
             <a:endParaRPr lang="en-US"/>
           </a:p>
@@ -1010,7 +1094,7 @@
           <a:p>
             <a:fld id="{E2316B49-29CB-5341-97D4-8A75BDD8022D}" type="datetimeFigureOut">
               <a:rPr lang="en-US" smtClean="0"/>
-              <a:t>10/29/25</a:t>
+              <a:t>11/3/25</a:t>
             </a:fld>
             <a:endParaRPr lang="en-US"/>
           </a:p>
@@ -1220,7 +1304,7 @@
           <a:p>
             <a:fld id="{E2316B49-29CB-5341-97D4-8A75BDD8022D}" type="datetimeFigureOut">
               <a:rPr lang="en-US" smtClean="0"/>
-              <a:t>10/29/25</a:t>
+              <a:t>11/3/25</a:t>
             </a:fld>
             <a:endParaRPr lang="en-US"/>
           </a:p>
@@ -1420,7 +1504,7 @@
           <a:p>
             <a:fld id="{E2316B49-29CB-5341-97D4-8A75BDD8022D}" type="datetimeFigureOut">
               <a:rPr lang="en-US" smtClean="0"/>
-              <a:t>10/29/25</a:t>
+              <a:t>11/3/25</a:t>
             </a:fld>
             <a:endParaRPr lang="en-US"/>
           </a:p>
@@ -1696,7 +1780,7 @@
           <a:p>
             <a:fld id="{E2316B49-29CB-5341-97D4-8A75BDD8022D}" type="datetimeFigureOut">
               <a:rPr lang="en-US" smtClean="0"/>
-              <a:t>10/29/25</a:t>
+              <a:t>11/3/25</a:t>
             </a:fld>
             <a:endParaRPr lang="en-US"/>
           </a:p>
@@ -1964,7 +2048,7 @@
           <a:p>
             <a:fld id="{E2316B49-29CB-5341-97D4-8A75BDD8022D}" type="datetimeFigureOut">
               <a:rPr lang="en-US" smtClean="0"/>
-              <a:t>10/29/25</a:t>
+              <a:t>11/3/25</a:t>
             </a:fld>
             <a:endParaRPr lang="en-US"/>
           </a:p>
@@ -2379,7 +2463,7 @@
           <a:p>
             <a:fld id="{E2316B49-29CB-5341-97D4-8A75BDD8022D}" type="datetimeFigureOut">
               <a:rPr lang="en-US" smtClean="0"/>
-              <a:t>10/29/25</a:t>
+              <a:t>11/3/25</a:t>
             </a:fld>
             <a:endParaRPr lang="en-US"/>
           </a:p>
@@ -2521,7 +2605,7 @@
           <a:p>
             <a:fld id="{E2316B49-29CB-5341-97D4-8A75BDD8022D}" type="datetimeFigureOut">
               <a:rPr lang="en-US" smtClean="0"/>
-              <a:t>10/29/25</a:t>
+              <a:t>11/3/25</a:t>
             </a:fld>
             <a:endParaRPr lang="en-US"/>
           </a:p>
@@ -2634,7 +2718,7 @@
           <a:p>
             <a:fld id="{E2316B49-29CB-5341-97D4-8A75BDD8022D}" type="datetimeFigureOut">
               <a:rPr lang="en-US" smtClean="0"/>
-              <a:t>10/29/25</a:t>
+              <a:t>11/3/25</a:t>
             </a:fld>
             <a:endParaRPr lang="en-US"/>
           </a:p>
@@ -2947,7 +3031,7 @@
           <a:p>
             <a:fld id="{E2316B49-29CB-5341-97D4-8A75BDD8022D}" type="datetimeFigureOut">
               <a:rPr lang="en-US" smtClean="0"/>
-              <a:t>10/29/25</a:t>
+              <a:t>11/3/25</a:t>
             </a:fld>
             <a:endParaRPr lang="en-US"/>
           </a:p>
@@ -3236,7 +3320,7 @@
           <a:p>
             <a:fld id="{E2316B49-29CB-5341-97D4-8A75BDD8022D}" type="datetimeFigureOut">
               <a:rPr lang="en-US" smtClean="0"/>
-              <a:t>10/29/25</a:t>
+              <a:t>11/3/25</a:t>
             </a:fld>
             <a:endParaRPr lang="en-US"/>
           </a:p>
@@ -3479,7 +3563,7 @@
           <a:p>
             <a:fld id="{E2316B49-29CB-5341-97D4-8A75BDD8022D}" type="datetimeFigureOut">
               <a:rPr lang="en-US" smtClean="0"/>
-              <a:t>10/29/25</a:t>
+              <a:t>11/3/25</a:t>
             </a:fld>
             <a:endParaRPr lang="en-US"/>
           </a:p>
@@ -4029,7 +4113,7 @@
         <p:spPr>
           <a:xfrm>
             <a:off x="3989567" y="393776"/>
-            <a:ext cx="7772400" cy="1973048"/>
+            <a:ext cx="7772399" cy="1973048"/>
           </a:xfrm>
           <a:prstGeom prst="rect">
             <a:avLst/>
@@ -4063,8 +4147,8 @@
         </p:blipFill>
         <p:spPr>
           <a:xfrm>
-            <a:off x="3989567" y="2594647"/>
-            <a:ext cx="7772400" cy="1967696"/>
+            <a:off x="4000108" y="2594647"/>
+            <a:ext cx="7751316" cy="1967696"/>
           </a:xfrm>
           <a:prstGeom prst="rect">
             <a:avLst/>
@@ -4133,8 +4217,8 @@
         </p:blipFill>
         <p:spPr>
           <a:xfrm>
-            <a:off x="4313571" y="4730889"/>
-            <a:ext cx="3927178" cy="1942847"/>
+            <a:off x="4313571" y="4732596"/>
+            <a:ext cx="3927178" cy="1939432"/>
           </a:xfrm>
           <a:prstGeom prst="rect">
             <a:avLst/>
@@ -4192,7 +4276,7 @@
           <p:nvPr/>
         </p:nvPicPr>
         <p:blipFill>
-          <a:blip r:embed="rId2"/>
+          <a:blip r:embed="rId3"/>
           <a:srcRect/>
           <a:stretch/>
         </p:blipFill>
@@ -4256,10 +4340,10 @@
           <p:nvPr/>
         </p:nvPicPr>
         <p:blipFill>
-          <a:blip r:embed="rId3">
+          <a:blip r:embed="rId4">
             <a:extLst>
               <a:ext uri="{96DAC541-7B7A-43D3-8B79-37D633B846F1}">
-                <asvg:svgBlip xmlns:asvg="http://schemas.microsoft.com/office/drawing/2016/SVG/main" r:embed="rId4"/>
+                <asvg:svgBlip xmlns:asvg="http://schemas.microsoft.com/office/drawing/2016/SVG/main" r:embed="rId5"/>
               </a:ext>
             </a:extLst>
           </a:blip>
@@ -4268,8 +4352,8 @@
         </p:blipFill>
         <p:spPr>
           <a:xfrm>
-            <a:off x="3989569" y="393777"/>
-            <a:ext cx="7772395" cy="1973046"/>
+            <a:off x="3989571" y="393777"/>
+            <a:ext cx="7772391" cy="1973046"/>
           </a:xfrm>
           <a:prstGeom prst="rect">
             <a:avLst/>
@@ -4291,10 +4375,10 @@
           <p:nvPr/>
         </p:nvPicPr>
         <p:blipFill>
-          <a:blip r:embed="rId5">
+          <a:blip r:embed="rId6">
             <a:extLst>
               <a:ext uri="{96DAC541-7B7A-43D3-8B79-37D633B846F1}">
-                <asvg:svgBlip xmlns:asvg="http://schemas.microsoft.com/office/drawing/2016/SVG/main" r:embed="rId6"/>
+                <asvg:svgBlip xmlns:asvg="http://schemas.microsoft.com/office/drawing/2016/SVG/main" r:embed="rId7"/>
               </a:ext>
             </a:extLst>
           </a:blip>
@@ -4303,8 +4387,8 @@
         </p:blipFill>
         <p:spPr>
           <a:xfrm>
-            <a:off x="4000139" y="2594655"/>
-            <a:ext cx="7751256" cy="1967680"/>
+            <a:off x="4000140" y="2594655"/>
+            <a:ext cx="7751253" cy="1967680"/>
           </a:xfrm>
           <a:prstGeom prst="rect">
             <a:avLst/>
@@ -4326,10 +4410,10 @@
           <p:nvPr/>
         </p:nvPicPr>
         <p:blipFill>
-          <a:blip r:embed="rId7">
+          <a:blip r:embed="rId8">
             <a:extLst>
               <a:ext uri="{96DAC541-7B7A-43D3-8B79-37D633B846F1}">
-                <asvg:svgBlip xmlns:asvg="http://schemas.microsoft.com/office/drawing/2016/SVG/main" r:embed="rId8"/>
+                <asvg:svgBlip xmlns:asvg="http://schemas.microsoft.com/office/drawing/2016/SVG/main" r:embed="rId9"/>
               </a:ext>
             </a:extLst>
           </a:blip>
@@ -4361,10 +4445,10 @@
           <p:nvPr/>
         </p:nvPicPr>
         <p:blipFill>
-          <a:blip r:embed="rId9">
+          <a:blip r:embed="rId10">
             <a:extLst>
               <a:ext uri="{96DAC541-7B7A-43D3-8B79-37D633B846F1}">
-                <asvg:svgBlip xmlns:asvg="http://schemas.microsoft.com/office/drawing/2016/SVG/main" r:embed="rId10"/>
+                <asvg:svgBlip xmlns:asvg="http://schemas.microsoft.com/office/drawing/2016/SVG/main" r:embed="rId11"/>
               </a:ext>
             </a:extLst>
           </a:blip>
@@ -4373,8 +4457,8 @@
         </p:blipFill>
         <p:spPr>
           <a:xfrm>
-            <a:off x="4313571" y="4730889"/>
-            <a:ext cx="3927178" cy="1942846"/>
+            <a:off x="4313571" y="4732596"/>
+            <a:ext cx="3927178" cy="1939432"/>
           </a:xfrm>
           <a:prstGeom prst="rect">
             <a:avLst/>
@@ -4396,10 +4480,10 @@
           <p:nvPr/>
         </p:nvPicPr>
         <p:blipFill>
-          <a:blip r:embed="rId11">
+          <a:blip r:embed="rId12">
             <a:extLst>
               <a:ext uri="{96DAC541-7B7A-43D3-8B79-37D633B846F1}">
-                <asvg:svgBlip xmlns:asvg="http://schemas.microsoft.com/office/drawing/2016/SVG/main" r:embed="rId12"/>
+                <asvg:svgBlip xmlns:asvg="http://schemas.microsoft.com/office/drawing/2016/SVG/main" r:embed="rId13"/>
               </a:ext>
             </a:extLst>
           </a:blip>
@@ -4408,8 +4492,8 @@
         </p:blipFill>
         <p:spPr>
           <a:xfrm>
-            <a:off x="8264823" y="4730888"/>
-            <a:ext cx="3927176" cy="1942846"/>
+            <a:off x="8264823" y="4732595"/>
+            <a:ext cx="3927176" cy="1939431"/>
           </a:xfrm>
           <a:prstGeom prst="rect">
             <a:avLst/>
@@ -4474,14 +4558,13 @@
               </a:ext>
             </a:extLst>
           </a:blip>
-          <a:stretch>
-            <a:fillRect/>
-          </a:stretch>
+          <a:srcRect/>
+          <a:stretch/>
         </p:blipFill>
         <p:spPr>
           <a:xfrm>
-            <a:off x="713678" y="3958683"/>
-            <a:ext cx="11009818" cy="2508231"/>
+            <a:off x="301084" y="4164189"/>
+            <a:ext cx="11818859" cy="1983730"/>
           </a:xfrm>
           <a:prstGeom prst="rect">
             <a:avLst/>
@@ -4510,14 +4593,13 @@
               </a:ext>
             </a:extLst>
           </a:blip>
-          <a:stretch>
-            <a:fillRect/>
-          </a:stretch>
+          <a:srcRect/>
+          <a:stretch/>
         </p:blipFill>
         <p:spPr>
           <a:xfrm>
-            <a:off x="713678" y="920769"/>
-            <a:ext cx="11009818" cy="2508231"/>
+            <a:off x="301085" y="1115122"/>
+            <a:ext cx="11818865" cy="1983731"/>
           </a:xfrm>
           <a:prstGeom prst="rect">
             <a:avLst/>
@@ -4537,8 +4619,8 @@
           <p:nvPr/>
         </p:nvSpPr>
         <p:spPr>
-          <a:xfrm rot="16200000">
-            <a:off x="208253" y="1990218"/>
+          <a:xfrm>
+            <a:off x="5602445" y="710081"/>
             <a:ext cx="641522" cy="369332"/>
           </a:xfrm>
           <a:prstGeom prst="rect">
@@ -4572,8 +4654,8 @@
           <p:nvPr/>
         </p:nvSpPr>
         <p:spPr>
-          <a:xfrm rot="16200000">
-            <a:off x="178813" y="5028132"/>
+          <a:xfrm>
+            <a:off x="5920818" y="3759148"/>
             <a:ext cx="579389" cy="369332"/>
           </a:xfrm>
           <a:prstGeom prst="rect">
@@ -4686,8 +4768,8 @@
         </p:blipFill>
         <p:spPr>
           <a:xfrm>
-            <a:off x="3989569" y="393777"/>
-            <a:ext cx="7772395" cy="1973046"/>
+            <a:off x="3989571" y="393777"/>
+            <a:ext cx="7772391" cy="1973046"/>
           </a:xfrm>
           <a:prstGeom prst="rect">
             <a:avLst/>
@@ -4721,8 +4803,8 @@
         </p:blipFill>
         <p:spPr>
           <a:xfrm>
-            <a:off x="4000139" y="2594655"/>
-            <a:ext cx="7751256" cy="1967680"/>
+            <a:off x="4000140" y="2594655"/>
+            <a:ext cx="7751253" cy="1967680"/>
           </a:xfrm>
           <a:prstGeom prst="rect">
             <a:avLst/>
@@ -4791,8 +4873,8 @@
         </p:blipFill>
         <p:spPr>
           <a:xfrm>
-            <a:off x="4313571" y="4730889"/>
-            <a:ext cx="3927178" cy="1942846"/>
+            <a:off x="4313571" y="4732596"/>
+            <a:ext cx="3927178" cy="1939432"/>
           </a:xfrm>
           <a:prstGeom prst="rect">
             <a:avLst/>
@@ -4826,8 +4908,8 @@
         </p:blipFill>
         <p:spPr>
           <a:xfrm>
-            <a:off x="8264823" y="4730888"/>
-            <a:ext cx="3927176" cy="1942846"/>
+            <a:off x="8264823" y="4732595"/>
+            <a:ext cx="3927176" cy="1939431"/>
           </a:xfrm>
           <a:prstGeom prst="rect">
             <a:avLst/>
@@ -4855,7 +4937,7 @@
         <p:cNvPr id="1" name="">
           <a:extLst>
             <a:ext uri="{FF2B5EF4-FFF2-40B4-BE49-F238E27FC236}">
-              <a16:creationId xmlns:a16="http://schemas.microsoft.com/office/drawing/2014/main" id="{CD41710D-AE0D-6C8A-341B-84CBA5E7F1E6}"/>
+              <a16:creationId xmlns:a16="http://schemas.microsoft.com/office/drawing/2014/main" id="{9770E8BB-0E9A-62A2-33D2-3217E987617F}"/>
             </a:ext>
           </a:extLst>
         </p:cNvPr>
@@ -4875,7 +4957,7 @@
           <p:cNvPr id="5" name="Graphic 4">
             <a:extLst>
               <a:ext uri="{FF2B5EF4-FFF2-40B4-BE49-F238E27FC236}">
-                <a16:creationId xmlns:a16="http://schemas.microsoft.com/office/drawing/2014/main" id="{5815A47F-F1F2-BBF2-033D-239BF98BE8EA}"/>
+                <a16:creationId xmlns:a16="http://schemas.microsoft.com/office/drawing/2014/main" id="{F940396B-8CC2-3161-E135-0201AF329D55}"/>
               </a:ext>
             </a:extLst>
           </p:cNvPr>
@@ -4897,8 +4979,8 @@
         </p:blipFill>
         <p:spPr>
           <a:xfrm>
-            <a:off x="713680" y="3958683"/>
-            <a:ext cx="11009813" cy="2508231"/>
+            <a:off x="301086" y="4164189"/>
+            <a:ext cx="11818854" cy="1983730"/>
           </a:xfrm>
           <a:prstGeom prst="rect">
             <a:avLst/>
@@ -4910,7 +4992,7 @@
           <p:cNvPr id="7" name="Graphic 6">
             <a:extLst>
               <a:ext uri="{FF2B5EF4-FFF2-40B4-BE49-F238E27FC236}">
-                <a16:creationId xmlns:a16="http://schemas.microsoft.com/office/drawing/2014/main" id="{5F699FC9-A82A-49A2-DC74-C59B8C096FBD}"/>
+                <a16:creationId xmlns:a16="http://schemas.microsoft.com/office/drawing/2014/main" id="{24334C0F-F2D0-9697-05E7-71E641AE8C77}"/>
               </a:ext>
             </a:extLst>
           </p:cNvPr>
@@ -4932,8 +5014,8 @@
         </p:blipFill>
         <p:spPr>
           <a:xfrm>
-            <a:off x="713680" y="920769"/>
-            <a:ext cx="11009813" cy="2508231"/>
+            <a:off x="301087" y="1115122"/>
+            <a:ext cx="11818860" cy="1983731"/>
           </a:xfrm>
           <a:prstGeom prst="rect">
             <a:avLst/>
@@ -4942,10 +5024,10 @@
       </p:pic>
       <p:sp>
         <p:nvSpPr>
-          <p:cNvPr id="2" name="TextBox 1">
-            <a:extLst>
-              <a:ext uri="{FF2B5EF4-FFF2-40B4-BE49-F238E27FC236}">
-                <a16:creationId xmlns:a16="http://schemas.microsoft.com/office/drawing/2014/main" id="{7DE44280-B751-95EA-DAF8-302F21EC2D20}"/>
+          <p:cNvPr id="8" name="TextBox 7">
+            <a:extLst>
+              <a:ext uri="{FF2B5EF4-FFF2-40B4-BE49-F238E27FC236}">
+                <a16:creationId xmlns:a16="http://schemas.microsoft.com/office/drawing/2014/main" id="{A08A30E0-11F2-65A6-B459-42D67A3733B1}"/>
               </a:ext>
             </a:extLst>
           </p:cNvPr>
@@ -4953,8 +5035,8 @@
           <p:nvPr/>
         </p:nvSpPr>
         <p:spPr>
-          <a:xfrm rot="16200000">
-            <a:off x="208253" y="1990218"/>
+          <a:xfrm>
+            <a:off x="5602445" y="710081"/>
             <a:ext cx="641522" cy="369332"/>
           </a:xfrm>
           <a:prstGeom prst="rect">
@@ -4977,10 +5059,10 @@
       </p:sp>
       <p:sp>
         <p:nvSpPr>
-          <p:cNvPr id="3" name="TextBox 2">
-            <a:extLst>
-              <a:ext uri="{FF2B5EF4-FFF2-40B4-BE49-F238E27FC236}">
-                <a16:creationId xmlns:a16="http://schemas.microsoft.com/office/drawing/2014/main" id="{36DA9544-4C84-BB96-1996-6EF88250FE98}"/>
+          <p:cNvPr id="9" name="TextBox 8">
+            <a:extLst>
+              <a:ext uri="{FF2B5EF4-FFF2-40B4-BE49-F238E27FC236}">
+                <a16:creationId xmlns:a16="http://schemas.microsoft.com/office/drawing/2014/main" id="{BF5BB6EB-4C5C-6192-3F8A-65ECA28E731B}"/>
               </a:ext>
             </a:extLst>
           </p:cNvPr>
@@ -4988,8 +5070,8 @@
           <p:nvPr/>
         </p:nvSpPr>
         <p:spPr>
-          <a:xfrm rot="16200000">
-            <a:off x="178813" y="5028132"/>
+          <a:xfrm>
+            <a:off x="5920818" y="3759148"/>
             <a:ext cx="579389" cy="369332"/>
           </a:xfrm>
           <a:prstGeom prst="rect">
@@ -5013,7 +5095,7 @@
     </p:spTree>
     <p:extLst>
       <p:ext uri="{BB962C8B-B14F-4D97-AF65-F5344CB8AC3E}">
-        <p14:creationId xmlns:p14="http://schemas.microsoft.com/office/powerpoint/2010/main" val="631085051"/>
+        <p14:creationId xmlns:p14="http://schemas.microsoft.com/office/powerpoint/2010/main" val="2979322939"/>
       </p:ext>
     </p:extLst>
   </p:cSld>

</xml_diff>